<commit_message>
ErrandBuddy is one word — fixed across all pages and components
</commit_message>
<xml_diff>
--- a/errand-buddy-deck.pptx
+++ b/errand-buddy-deck.pptx
@@ -1569,7 +1569,7 @@
     <p:bg>
       <p:bgPr>
         <a:solidFill>
-          <a:srgbClr val="1E3A5F"/>
+          <a:srgbClr val="1C1917"/>
         </a:solidFill>
       </p:bgPr>
     </p:bg>
@@ -1602,7 +1602,7 @@
             <a:avLst/>
           </a:prstGeom>
           <a:solidFill>
-            <a:srgbClr val="0D9488"/>
+            <a:srgbClr val="10B981"/>
           </a:solidFill>
           <a:ln/>
         </p:spPr>
@@ -1622,7 +1622,7 @@
             <a:avLst/>
           </a:prstGeom>
           <a:solidFill>
-            <a:srgbClr val="0D9488">
+            <a:srgbClr val="10B981">
               <a:alpha val="15000"/>
             </a:srgbClr>
           </a:solidFill>
@@ -1644,7 +1644,7 @@
             <a:avLst/>
           </a:prstGeom>
           <a:solidFill>
-            <a:srgbClr val="0D9488">
+            <a:srgbClr val="10B981">
               <a:alpha val="30000"/>
             </a:srgbClr>
           </a:solidFill>
@@ -1717,7 +1717,7 @@
             <a:r>
               <a:rPr lang="en-US" sz="2000" dirty="0">
                 <a:solidFill>
-                  <a:srgbClr val="CCFBF1"/>
+                  <a:srgbClr val="D1FAE5"/>
                 </a:solidFill>
                 <a:latin typeface="Calibri" pitchFamily="34" charset="0"/>
                 <a:ea typeface="Calibri" pitchFamily="34" charset="-122"/>
@@ -1776,7 +1776,7 @@
             <a:r>
               <a:rPr lang="en-US" sz="1300" dirty="0">
                 <a:solidFill>
-                  <a:srgbClr val="64748B"/>
+                  <a:srgbClr val="78716C"/>
                 </a:solidFill>
                 <a:latin typeface="Calibri" pitchFamily="34" charset="0"/>
                 <a:ea typeface="Calibri" pitchFamily="34" charset="-122"/>
@@ -1802,7 +1802,7 @@
     <p:bg>
       <p:bgPr>
         <a:solidFill>
-          <a:srgbClr val="F8F7F4"/>
+          <a:srgbClr val="FAFAF9"/>
         </a:solidFill>
       </p:bgPr>
     </p:bg>
@@ -1835,7 +1835,7 @@
             <a:avLst/>
           </a:prstGeom>
           <a:solidFill>
-            <a:srgbClr val="1E3A5F"/>
+            <a:srgbClr val="1C1917"/>
           </a:solidFill>
           <a:ln/>
         </p:spPr>
@@ -1906,7 +1906,7 @@
             <a:r>
               <a:rPr lang="en-US" sz="1600" i="1" dirty="0">
                 <a:solidFill>
-                  <a:srgbClr val="1E293B"/>
+                  <a:srgbClr val="1C1917"/>
                 </a:solidFill>
                 <a:latin typeface="Calibri" pitchFamily="34" charset="0"/>
                 <a:ea typeface="Calibri" pitchFamily="34" charset="-122"/>
@@ -1937,7 +1937,7 @@
           </a:solidFill>
           <a:ln w="6350">
             <a:solidFill>
-              <a:srgbClr val="E2E8F0"/>
+              <a:srgbClr val="E7E5E4"/>
             </a:solidFill>
             <a:prstDash val="solid"/>
           </a:ln>
@@ -1965,7 +1965,7 @@
             <a:avLst/>
           </a:prstGeom>
           <a:solidFill>
-            <a:srgbClr val="0D9488"/>
+            <a:srgbClr val="10B981"/>
           </a:solidFill>
           <a:ln/>
         </p:spPr>
@@ -1997,7 +1997,7 @@
             <a:r>
               <a:rPr lang="en-US" sz="1300" b="1" dirty="0">
                 <a:solidFill>
-                  <a:srgbClr val="1E3A5F"/>
+                  <a:srgbClr val="1C1917"/>
                 </a:solidFill>
                 <a:latin typeface="Calibri" pitchFamily="34" charset="0"/>
                 <a:ea typeface="Calibri" pitchFamily="34" charset="-122"/>
@@ -2036,7 +2036,7 @@
             <a:r>
               <a:rPr lang="en-US" sz="1150" dirty="0">
                 <a:solidFill>
-                  <a:srgbClr val="1E293B"/>
+                  <a:srgbClr val="1C1917"/>
                 </a:solidFill>
                 <a:latin typeface="Calibri" pitchFamily="34" charset="0"/>
                 <a:ea typeface="Calibri" pitchFamily="34" charset="-122"/>
@@ -2067,7 +2067,7 @@
           </a:solidFill>
           <a:ln w="6350">
             <a:solidFill>
-              <a:srgbClr val="E2E8F0"/>
+              <a:srgbClr val="E7E5E4"/>
             </a:solidFill>
             <a:prstDash val="solid"/>
           </a:ln>
@@ -2095,7 +2095,7 @@
             <a:avLst/>
           </a:prstGeom>
           <a:solidFill>
-            <a:srgbClr val="0D9488"/>
+            <a:srgbClr val="10B981"/>
           </a:solidFill>
           <a:ln/>
         </p:spPr>
@@ -2127,7 +2127,7 @@
             <a:r>
               <a:rPr lang="en-US" sz="1300" b="1" dirty="0">
                 <a:solidFill>
-                  <a:srgbClr val="1E3A5F"/>
+                  <a:srgbClr val="1C1917"/>
                 </a:solidFill>
                 <a:latin typeface="Calibri" pitchFamily="34" charset="0"/>
                 <a:ea typeface="Calibri" pitchFamily="34" charset="-122"/>
@@ -2166,7 +2166,7 @@
             <a:r>
               <a:rPr lang="en-US" sz="1150" dirty="0">
                 <a:solidFill>
-                  <a:srgbClr val="1E293B"/>
+                  <a:srgbClr val="1C1917"/>
                 </a:solidFill>
                 <a:latin typeface="Calibri" pitchFamily="34" charset="0"/>
                 <a:ea typeface="Calibri" pitchFamily="34" charset="-122"/>
@@ -2197,7 +2197,7 @@
           </a:solidFill>
           <a:ln w="6350">
             <a:solidFill>
-              <a:srgbClr val="E2E8F0"/>
+              <a:srgbClr val="E7E5E4"/>
             </a:solidFill>
             <a:prstDash val="solid"/>
           </a:ln>
@@ -2225,7 +2225,7 @@
             <a:avLst/>
           </a:prstGeom>
           <a:solidFill>
-            <a:srgbClr val="0D9488"/>
+            <a:srgbClr val="10B981"/>
           </a:solidFill>
           <a:ln/>
         </p:spPr>
@@ -2257,7 +2257,7 @@
             <a:r>
               <a:rPr lang="en-US" sz="1300" b="1" dirty="0">
                 <a:solidFill>
-                  <a:srgbClr val="1E3A5F"/>
+                  <a:srgbClr val="1C1917"/>
                 </a:solidFill>
                 <a:latin typeface="Calibri" pitchFamily="34" charset="0"/>
                 <a:ea typeface="Calibri" pitchFamily="34" charset="-122"/>
@@ -2296,7 +2296,7 @@
             <a:r>
               <a:rPr lang="en-US" sz="1150" dirty="0">
                 <a:solidFill>
-                  <a:srgbClr val="1E293B"/>
+                  <a:srgbClr val="1C1917"/>
                 </a:solidFill>
                 <a:latin typeface="Calibri" pitchFamily="34" charset="0"/>
                 <a:ea typeface="Calibri" pitchFamily="34" charset="-122"/>
@@ -2323,7 +2323,7 @@
             <a:avLst/>
           </a:prstGeom>
           <a:solidFill>
-            <a:srgbClr val="CCFBF1"/>
+            <a:srgbClr val="D1FAE5"/>
           </a:solidFill>
           <a:ln/>
         </p:spPr>
@@ -2355,7 +2355,7 @@
             <a:r>
               <a:rPr lang="en-US" sz="1200" b="1" dirty="0">
                 <a:solidFill>
-                  <a:srgbClr val="1E3A5F"/>
+                  <a:srgbClr val="1C1917"/>
                 </a:solidFill>
                 <a:latin typeface="Calibri" pitchFamily="34" charset="0"/>
                 <a:ea typeface="Calibri" pitchFamily="34" charset="-122"/>
@@ -2381,7 +2381,7 @@
     <p:bg>
       <p:bgPr>
         <a:solidFill>
-          <a:srgbClr val="1E3A5F"/>
+          <a:srgbClr val="1C1917"/>
         </a:solidFill>
       </p:bgPr>
     </p:bg>
@@ -2414,7 +2414,7 @@
             <a:avLst/>
           </a:prstGeom>
           <a:solidFill>
-            <a:srgbClr val="0D9488">
+            <a:srgbClr val="10B981">
               <a:alpha val="20000"/>
             </a:srgbClr>
           </a:solidFill>
@@ -2487,7 +2487,7 @@
             <a:r>
               <a:rPr lang="en-US" sz="1600" dirty="0">
                 <a:solidFill>
-                  <a:srgbClr val="CCFBF1"/>
+                  <a:srgbClr val="D1FAE5"/>
                 </a:solidFill>
                 <a:latin typeface="Calibri" pitchFamily="34" charset="0"/>
                 <a:ea typeface="Calibri" pitchFamily="34" charset="-122"/>
@@ -2504,7 +2504,7 @@
             <a:r>
               <a:rPr lang="en-US" sz="1600" dirty="0">
                 <a:solidFill>
-                  <a:srgbClr val="CCFBF1"/>
+                  <a:srgbClr val="D1FAE5"/>
                 </a:solidFill>
                 <a:latin typeface="Calibri" pitchFamily="34" charset="0"/>
                 <a:ea typeface="Calibri" pitchFamily="34" charset="-122"/>
@@ -2531,7 +2531,7 @@
             <a:avLst/>
           </a:prstGeom>
           <a:solidFill>
-            <a:srgbClr val="0D9488">
+            <a:srgbClr val="10B981">
               <a:alpha val="25000"/>
             </a:srgbClr>
           </a:solidFill>
@@ -2628,7 +2628,7 @@
             <a:r>
               <a:rPr lang="en-US" sz="1100" dirty="0">
                 <a:solidFill>
-                  <a:srgbClr val="CCFBF1"/>
+                  <a:srgbClr val="D1FAE5"/>
                 </a:solidFill>
                 <a:latin typeface="Calibri" pitchFamily="34" charset="0"/>
                 <a:ea typeface="Calibri" pitchFamily="34" charset="-122"/>
@@ -2655,7 +2655,7 @@
             <a:avLst/>
           </a:prstGeom>
           <a:solidFill>
-            <a:srgbClr val="0D9488">
+            <a:srgbClr val="10B981">
               <a:alpha val="25000"/>
             </a:srgbClr>
           </a:solidFill>
@@ -2752,7 +2752,7 @@
             <a:r>
               <a:rPr lang="en-US" sz="1100" dirty="0">
                 <a:solidFill>
-                  <a:srgbClr val="CCFBF1"/>
+                  <a:srgbClr val="D1FAE5"/>
                 </a:solidFill>
                 <a:latin typeface="Calibri" pitchFamily="34" charset="0"/>
                 <a:ea typeface="Calibri" pitchFamily="34" charset="-122"/>
@@ -2779,7 +2779,7 @@
             <a:avLst/>
           </a:prstGeom>
           <a:solidFill>
-            <a:srgbClr val="0D9488">
+            <a:srgbClr val="10B981">
               <a:alpha val="25000"/>
             </a:srgbClr>
           </a:solidFill>
@@ -2876,7 +2876,7 @@
             <a:r>
               <a:rPr lang="en-US" sz="1100" dirty="0">
                 <a:solidFill>
-                  <a:srgbClr val="CCFBF1"/>
+                  <a:srgbClr val="D1FAE5"/>
                 </a:solidFill>
                 <a:latin typeface="Calibri" pitchFamily="34" charset="0"/>
                 <a:ea typeface="Calibri" pitchFamily="34" charset="-122"/>
@@ -2902,7 +2902,7 @@
     <p:bg>
       <p:bgPr>
         <a:solidFill>
-          <a:srgbClr val="F8F7F4"/>
+          <a:srgbClr val="FAFAF9"/>
         </a:solidFill>
       </p:bgPr>
     </p:bg>
@@ -2935,7 +2935,7 @@
             <a:avLst/>
           </a:prstGeom>
           <a:solidFill>
-            <a:srgbClr val="1E3A5F"/>
+            <a:srgbClr val="1C1917"/>
           </a:solidFill>
           <a:ln/>
         </p:spPr>
@@ -2994,7 +2994,7 @@
             <a:avLst/>
           </a:prstGeom>
           <a:solidFill>
-            <a:srgbClr val="0D9488"/>
+            <a:srgbClr val="10B981"/>
           </a:solidFill>
           <a:ln/>
         </p:spPr>
@@ -3053,7 +3053,7 @@
             <a:avLst/>
           </a:prstGeom>
           <a:solidFill>
-            <a:srgbClr val="0D9488"/>
+            <a:srgbClr val="10B981"/>
           </a:solidFill>
           <a:ln/>
         </p:spPr>
@@ -3077,7 +3077,7 @@
           </a:solidFill>
           <a:ln w="6350">
             <a:solidFill>
-              <a:srgbClr val="E2E8F0"/>
+              <a:srgbClr val="E7E5E4"/>
             </a:solidFill>
             <a:prstDash val="solid"/>
           </a:ln>
@@ -3117,7 +3117,7 @@
             <a:r>
               <a:rPr lang="en-US" sz="1700" b="1" dirty="0">
                 <a:solidFill>
-                  <a:srgbClr val="1E3A5F"/>
+                  <a:srgbClr val="1C1917"/>
                 </a:solidFill>
                 <a:latin typeface="Georgia" pitchFamily="34" charset="0"/>
                 <a:ea typeface="Georgia" pitchFamily="34" charset="-122"/>
@@ -3156,7 +3156,7 @@
             <a:r>
               <a:rPr lang="en-US" sz="1150" dirty="0">
                 <a:solidFill>
-                  <a:srgbClr val="1E293B"/>
+                  <a:srgbClr val="1C1917"/>
                 </a:solidFill>
                 <a:latin typeface="Calibri" pitchFamily="34" charset="0"/>
                 <a:ea typeface="Calibri" pitchFamily="34" charset="-122"/>
@@ -3183,7 +3183,7 @@
             <a:avLst/>
           </a:prstGeom>
           <a:solidFill>
-            <a:srgbClr val="0D9488"/>
+            <a:srgbClr val="10B981"/>
           </a:solidFill>
           <a:ln/>
         </p:spPr>
@@ -3242,7 +3242,7 @@
             <a:avLst/>
           </a:prstGeom>
           <a:solidFill>
-            <a:srgbClr val="0D9488"/>
+            <a:srgbClr val="10B981"/>
           </a:solidFill>
           <a:ln/>
         </p:spPr>
@@ -3266,7 +3266,7 @@
           </a:solidFill>
           <a:ln w="6350">
             <a:solidFill>
-              <a:srgbClr val="E2E8F0"/>
+              <a:srgbClr val="E7E5E4"/>
             </a:solidFill>
             <a:prstDash val="solid"/>
           </a:ln>
@@ -3306,7 +3306,7 @@
             <a:r>
               <a:rPr lang="en-US" sz="1700" b="1" dirty="0">
                 <a:solidFill>
-                  <a:srgbClr val="1E3A5F"/>
+                  <a:srgbClr val="1C1917"/>
                 </a:solidFill>
                 <a:latin typeface="Georgia" pitchFamily="34" charset="0"/>
                 <a:ea typeface="Georgia" pitchFamily="34" charset="-122"/>
@@ -3345,7 +3345,7 @@
             <a:r>
               <a:rPr lang="en-US" sz="1150" dirty="0">
                 <a:solidFill>
-                  <a:srgbClr val="1E293B"/>
+                  <a:srgbClr val="1C1917"/>
                 </a:solidFill>
                 <a:latin typeface="Calibri" pitchFamily="34" charset="0"/>
                 <a:ea typeface="Calibri" pitchFamily="34" charset="-122"/>
@@ -3372,7 +3372,7 @@
             <a:avLst/>
           </a:prstGeom>
           <a:solidFill>
-            <a:srgbClr val="0D9488"/>
+            <a:srgbClr val="10B981"/>
           </a:solidFill>
           <a:ln/>
         </p:spPr>
@@ -3435,7 +3435,7 @@
           </a:solidFill>
           <a:ln w="6350">
             <a:solidFill>
-              <a:srgbClr val="E2E8F0"/>
+              <a:srgbClr val="E7E5E4"/>
             </a:solidFill>
             <a:prstDash val="solid"/>
           </a:ln>
@@ -3475,7 +3475,7 @@
             <a:r>
               <a:rPr lang="en-US" sz="1700" b="1" dirty="0">
                 <a:solidFill>
-                  <a:srgbClr val="1E3A5F"/>
+                  <a:srgbClr val="1C1917"/>
                 </a:solidFill>
                 <a:latin typeface="Georgia" pitchFamily="34" charset="0"/>
                 <a:ea typeface="Georgia" pitchFamily="34" charset="-122"/>
@@ -3514,7 +3514,7 @@
             <a:r>
               <a:rPr lang="en-US" sz="1150" dirty="0">
                 <a:solidFill>
-                  <a:srgbClr val="1E293B"/>
+                  <a:srgbClr val="1C1917"/>
                 </a:solidFill>
                 <a:latin typeface="Calibri" pitchFamily="34" charset="0"/>
                 <a:ea typeface="Calibri" pitchFamily="34" charset="-122"/>
@@ -3540,7 +3540,7 @@
     <p:bg>
       <p:bgPr>
         <a:solidFill>
-          <a:srgbClr val="F8F7F4"/>
+          <a:srgbClr val="FAFAF9"/>
         </a:solidFill>
       </p:bgPr>
     </p:bg>
@@ -3573,7 +3573,7 @@
             <a:avLst/>
           </a:prstGeom>
           <a:solidFill>
-            <a:srgbClr val="0D9488"/>
+            <a:srgbClr val="10B981"/>
           </a:solidFill>
           <a:ln/>
         </p:spPr>
@@ -3632,7 +3632,7 @@
             <a:avLst/>
           </a:prstGeom>
           <a:solidFill>
-            <a:srgbClr val="CCFBF1"/>
+            <a:srgbClr val="D1FAE5"/>
           </a:solidFill>
           <a:ln/>
         </p:spPr>
@@ -3688,7 +3688,7 @@
             <a:r>
               <a:rPr lang="en-US" sz="1200" b="1" dirty="0">
                 <a:solidFill>
-                  <a:srgbClr val="1E3A5F"/>
+                  <a:srgbClr val="1C1917"/>
                 </a:solidFill>
                 <a:latin typeface="Calibri" pitchFamily="34" charset="0"/>
                 <a:ea typeface="Calibri" pitchFamily="34" charset="-122"/>
@@ -3705,7 +3705,7 @@
             <a:r>
               <a:rPr lang="en-US" sz="1200" b="1" dirty="0">
                 <a:solidFill>
-                  <a:srgbClr val="1E3A5F"/>
+                  <a:srgbClr val="1C1917"/>
                 </a:solidFill>
                 <a:latin typeface="Calibri" pitchFamily="34" charset="0"/>
                 <a:ea typeface="Calibri" pitchFamily="34" charset="-122"/>
@@ -3732,7 +3732,7 @@
             <a:avLst/>
           </a:prstGeom>
           <a:solidFill>
-            <a:srgbClr val="CCFBF1"/>
+            <a:srgbClr val="D1FAE5"/>
           </a:solidFill>
           <a:ln/>
         </p:spPr>
@@ -3788,7 +3788,7 @@
             <a:r>
               <a:rPr lang="en-US" sz="1200" b="1" dirty="0">
                 <a:solidFill>
-                  <a:srgbClr val="1E3A5F"/>
+                  <a:srgbClr val="1C1917"/>
                 </a:solidFill>
                 <a:latin typeface="Calibri" pitchFamily="34" charset="0"/>
                 <a:ea typeface="Calibri" pitchFamily="34" charset="-122"/>
@@ -3805,7 +3805,7 @@
             <a:r>
               <a:rPr lang="en-US" sz="1200" b="1" dirty="0">
                 <a:solidFill>
-                  <a:srgbClr val="1E3A5F"/>
+                  <a:srgbClr val="1C1917"/>
                 </a:solidFill>
                 <a:latin typeface="Calibri" pitchFamily="34" charset="0"/>
                 <a:ea typeface="Calibri" pitchFamily="34" charset="-122"/>
@@ -3832,7 +3832,7 @@
             <a:avLst/>
           </a:prstGeom>
           <a:solidFill>
-            <a:srgbClr val="CCFBF1"/>
+            <a:srgbClr val="D1FAE5"/>
           </a:solidFill>
           <a:ln/>
         </p:spPr>
@@ -3888,7 +3888,7 @@
             <a:r>
               <a:rPr lang="en-US" sz="1200" b="1" dirty="0">
                 <a:solidFill>
-                  <a:srgbClr val="1E3A5F"/>
+                  <a:srgbClr val="1C1917"/>
                 </a:solidFill>
                 <a:latin typeface="Calibri" pitchFamily="34" charset="0"/>
                 <a:ea typeface="Calibri" pitchFamily="34" charset="-122"/>
@@ -3905,7 +3905,7 @@
             <a:r>
               <a:rPr lang="en-US" sz="1200" b="1" dirty="0">
                 <a:solidFill>
-                  <a:srgbClr val="1E3A5F"/>
+                  <a:srgbClr val="1C1917"/>
                 </a:solidFill>
                 <a:latin typeface="Calibri" pitchFamily="34" charset="0"/>
                 <a:ea typeface="Calibri" pitchFamily="34" charset="-122"/>
@@ -3932,7 +3932,7 @@
             <a:avLst/>
           </a:prstGeom>
           <a:solidFill>
-            <a:srgbClr val="CCFBF1"/>
+            <a:srgbClr val="D1FAE5"/>
           </a:solidFill>
           <a:ln/>
         </p:spPr>
@@ -3988,7 +3988,7 @@
             <a:r>
               <a:rPr lang="en-US" sz="1200" b="1" dirty="0">
                 <a:solidFill>
-                  <a:srgbClr val="1E3A5F"/>
+                  <a:srgbClr val="1C1917"/>
                 </a:solidFill>
                 <a:latin typeface="Calibri" pitchFamily="34" charset="0"/>
                 <a:ea typeface="Calibri" pitchFamily="34" charset="-122"/>
@@ -4005,7 +4005,7 @@
             <a:r>
               <a:rPr lang="en-US" sz="1200" b="1" dirty="0">
                 <a:solidFill>
-                  <a:srgbClr val="1E3A5F"/>
+                  <a:srgbClr val="1C1917"/>
                 </a:solidFill>
                 <a:latin typeface="Calibri" pitchFamily="34" charset="0"/>
                 <a:ea typeface="Calibri" pitchFamily="34" charset="-122"/>
@@ -4032,7 +4032,7 @@
             <a:avLst/>
           </a:prstGeom>
           <a:solidFill>
-            <a:srgbClr val="CCFBF1"/>
+            <a:srgbClr val="D1FAE5"/>
           </a:solidFill>
           <a:ln/>
         </p:spPr>
@@ -4088,7 +4088,7 @@
             <a:r>
               <a:rPr lang="en-US" sz="1200" b="1" dirty="0">
                 <a:solidFill>
-                  <a:srgbClr val="1E3A5F"/>
+                  <a:srgbClr val="1C1917"/>
                 </a:solidFill>
                 <a:latin typeface="Calibri" pitchFamily="34" charset="0"/>
                 <a:ea typeface="Calibri" pitchFamily="34" charset="-122"/>
@@ -4105,7 +4105,7 @@
             <a:r>
               <a:rPr lang="en-US" sz="1200" b="1" dirty="0">
                 <a:solidFill>
-                  <a:srgbClr val="1E3A5F"/>
+                  <a:srgbClr val="1C1917"/>
                 </a:solidFill>
                 <a:latin typeface="Calibri" pitchFamily="34" charset="0"/>
                 <a:ea typeface="Calibri" pitchFamily="34" charset="-122"/>
@@ -4132,7 +4132,7 @@
             <a:avLst/>
           </a:prstGeom>
           <a:solidFill>
-            <a:srgbClr val="1E3A5F"/>
+            <a:srgbClr val="1C1917"/>
           </a:solidFill>
           <a:ln/>
         </p:spPr>
@@ -4164,7 +4164,7 @@
             <a:r>
               <a:rPr lang="en-US" sz="1400" i="1" dirty="0">
                 <a:solidFill>
-                  <a:srgbClr val="CCFBF1"/>
+                  <a:srgbClr val="D1FAE5"/>
                 </a:solidFill>
                 <a:latin typeface="Calibri" pitchFamily="34" charset="0"/>
                 <a:ea typeface="Calibri" pitchFamily="34" charset="-122"/>
@@ -4266,7 +4266,7 @@
             <a:r>
               <a:rPr lang="en-US" sz="1100" dirty="0">
                 <a:solidFill>
-                  <a:srgbClr val="CCFBF1"/>
+                  <a:srgbClr val="D1FAE5"/>
                 </a:solidFill>
                 <a:latin typeface="Calibri" pitchFamily="34" charset="0"/>
                 <a:ea typeface="Calibri" pitchFamily="34" charset="-122"/>
@@ -4368,7 +4368,7 @@
             <a:r>
               <a:rPr lang="en-US" sz="1100" dirty="0">
                 <a:solidFill>
-                  <a:srgbClr val="CCFBF1"/>
+                  <a:srgbClr val="D1FAE5"/>
                 </a:solidFill>
                 <a:latin typeface="Calibri" pitchFamily="34" charset="0"/>
                 <a:ea typeface="Calibri" pitchFamily="34" charset="-122"/>
@@ -4394,7 +4394,7 @@
     <p:bg>
       <p:bgPr>
         <a:solidFill>
-          <a:srgbClr val="F8F7F4"/>
+          <a:srgbClr val="FAFAF9"/>
         </a:solidFill>
       </p:bgPr>
     </p:bg>
@@ -4427,7 +4427,7 @@
             <a:avLst/>
           </a:prstGeom>
           <a:solidFill>
-            <a:srgbClr val="1E3A5F"/>
+            <a:srgbClr val="1C1917"/>
           </a:solidFill>
           <a:ln/>
         </p:spPr>
@@ -4486,7 +4486,7 @@
             <a:avLst/>
           </a:prstGeom>
           <a:solidFill>
-            <a:srgbClr val="1E3A5F"/>
+            <a:srgbClr val="1C1917"/>
           </a:solidFill>
           <a:ln/>
         </p:spPr>
@@ -4518,7 +4518,7 @@
             <a:r>
               <a:rPr lang="en-US" sz="1300" b="1" spc="300" kern="0" dirty="0">
                 <a:solidFill>
-                  <a:srgbClr val="CCFBF1"/>
+                  <a:srgbClr val="D1FAE5"/>
                 </a:solidFill>
                 <a:latin typeface="Calibri" pitchFamily="34" charset="0"/>
                 <a:ea typeface="Calibri" pitchFamily="34" charset="-122"/>
@@ -4836,7 +4836,7 @@
             <a:avLst/>
           </a:prstGeom>
           <a:solidFill>
-            <a:srgbClr val="0D9488"/>
+            <a:srgbClr val="10B981"/>
           </a:solidFill>
           <a:ln/>
         </p:spPr>
@@ -4868,7 +4868,7 @@
             <a:r>
               <a:rPr lang="en-US" sz="1300" b="1" spc="300" kern="0" dirty="0">
                 <a:solidFill>
-                  <a:srgbClr val="1E3A5F"/>
+                  <a:srgbClr val="FFFFFF"/>
                 </a:solidFill>
                 <a:latin typeface="Calibri" pitchFamily="34" charset="0"/>
                 <a:ea typeface="Calibri" pitchFamily="34" charset="-122"/>
@@ -5244,7 +5244,7 @@
     <p:bg>
       <p:bgPr>
         <a:solidFill>
-          <a:srgbClr val="F8F7F4"/>
+          <a:srgbClr val="FAFAF9"/>
         </a:solidFill>
       </p:bgPr>
     </p:bg>
@@ -5277,7 +5277,7 @@
             <a:avLst/>
           </a:prstGeom>
           <a:solidFill>
-            <a:srgbClr val="0D9488"/>
+            <a:srgbClr val="10B981"/>
           </a:solidFill>
           <a:ln/>
         </p:spPr>
@@ -5348,7 +5348,7 @@
             <a:r>
               <a:rPr lang="en-US" sz="1400" i="1" dirty="0">
                 <a:solidFill>
-                  <a:srgbClr val="1E293B"/>
+                  <a:srgbClr val="1C1917"/>
                 </a:solidFill>
                 <a:latin typeface="Calibri" pitchFamily="34" charset="0"/>
                 <a:ea typeface="Calibri" pitchFamily="34" charset="-122"/>
@@ -5379,7 +5379,7 @@
           </a:solidFill>
           <a:ln w="6350">
             <a:solidFill>
-              <a:srgbClr val="E2E8F0"/>
+              <a:srgbClr val="E7E5E4"/>
             </a:solidFill>
             <a:prstDash val="solid"/>
           </a:ln>
@@ -5407,7 +5407,7 @@
             <a:avLst/>
           </a:prstGeom>
           <a:solidFill>
-            <a:srgbClr val="0D9488"/>
+            <a:srgbClr val="10B981"/>
           </a:solidFill>
           <a:ln/>
         </p:spPr>
@@ -5439,7 +5439,7 @@
             <a:r>
               <a:rPr lang="en-US" sz="1300" b="1" dirty="0">
                 <a:solidFill>
-                  <a:srgbClr val="1E3A5F"/>
+                  <a:srgbClr val="1C1917"/>
                 </a:solidFill>
                 <a:latin typeface="Calibri" pitchFamily="34" charset="0"/>
                 <a:ea typeface="Calibri" pitchFamily="34" charset="-122"/>
@@ -5478,7 +5478,7 @@
             <a:r>
               <a:rPr lang="en-US" sz="1150" dirty="0">
                 <a:solidFill>
-                  <a:srgbClr val="1E293B"/>
+                  <a:srgbClr val="1C1917"/>
                 </a:solidFill>
                 <a:latin typeface="Calibri" pitchFamily="34" charset="0"/>
                 <a:ea typeface="Calibri" pitchFamily="34" charset="-122"/>
@@ -5509,7 +5509,7 @@
           </a:solidFill>
           <a:ln w="6350">
             <a:solidFill>
-              <a:srgbClr val="E2E8F0"/>
+              <a:srgbClr val="E7E5E4"/>
             </a:solidFill>
             <a:prstDash val="solid"/>
           </a:ln>
@@ -5537,7 +5537,7 @@
             <a:avLst/>
           </a:prstGeom>
           <a:solidFill>
-            <a:srgbClr val="0D9488"/>
+            <a:srgbClr val="10B981"/>
           </a:solidFill>
           <a:ln/>
         </p:spPr>
@@ -5569,7 +5569,7 @@
             <a:r>
               <a:rPr lang="en-US" sz="1300" b="1" dirty="0">
                 <a:solidFill>
-                  <a:srgbClr val="1E3A5F"/>
+                  <a:srgbClr val="1C1917"/>
                 </a:solidFill>
                 <a:latin typeface="Calibri" pitchFamily="34" charset="0"/>
                 <a:ea typeface="Calibri" pitchFamily="34" charset="-122"/>
@@ -5608,7 +5608,7 @@
             <a:r>
               <a:rPr lang="en-US" sz="1150" dirty="0">
                 <a:solidFill>
-                  <a:srgbClr val="1E293B"/>
+                  <a:srgbClr val="1C1917"/>
                 </a:solidFill>
                 <a:latin typeface="Calibri" pitchFamily="34" charset="0"/>
                 <a:ea typeface="Calibri" pitchFamily="34" charset="-122"/>
@@ -5639,7 +5639,7 @@
           </a:solidFill>
           <a:ln w="6350">
             <a:solidFill>
-              <a:srgbClr val="E2E8F0"/>
+              <a:srgbClr val="E7E5E4"/>
             </a:solidFill>
             <a:prstDash val="solid"/>
           </a:ln>
@@ -5667,7 +5667,7 @@
             <a:avLst/>
           </a:prstGeom>
           <a:solidFill>
-            <a:srgbClr val="0D9488"/>
+            <a:srgbClr val="10B981"/>
           </a:solidFill>
           <a:ln/>
         </p:spPr>
@@ -5699,7 +5699,7 @@
             <a:r>
               <a:rPr lang="en-US" sz="1300" b="1" dirty="0">
                 <a:solidFill>
-                  <a:srgbClr val="1E3A5F"/>
+                  <a:srgbClr val="1C1917"/>
                 </a:solidFill>
                 <a:latin typeface="Calibri" pitchFamily="34" charset="0"/>
                 <a:ea typeface="Calibri" pitchFamily="34" charset="-122"/>
@@ -5738,7 +5738,7 @@
             <a:r>
               <a:rPr lang="en-US" sz="1150" dirty="0">
                 <a:solidFill>
-                  <a:srgbClr val="1E293B"/>
+                  <a:srgbClr val="1C1917"/>
                 </a:solidFill>
                 <a:latin typeface="Calibri" pitchFamily="34" charset="0"/>
                 <a:ea typeface="Calibri" pitchFamily="34" charset="-122"/>
@@ -5764,7 +5764,7 @@
     <p:bg>
       <p:bgPr>
         <a:solidFill>
-          <a:srgbClr val="F8F7F4"/>
+          <a:srgbClr val="FAFAF9"/>
         </a:solidFill>
       </p:bgPr>
     </p:bg>
@@ -5797,7 +5797,7 @@
             <a:avLst/>
           </a:prstGeom>
           <a:solidFill>
-            <a:srgbClr val="1E3A5F"/>
+            <a:srgbClr val="1C1917"/>
           </a:solidFill>
           <a:ln/>
         </p:spPr>
@@ -5892,7 +5892,7 @@
             <a:r>
               <a:rPr lang="en-US" sz="1300" b="1" dirty="0">
                 <a:solidFill>
-                  <a:srgbClr val="1E3A5F"/>
+                  <a:srgbClr val="1C1917"/>
                 </a:solidFill>
                 <a:latin typeface="Calibri" pitchFamily="34" charset="0"/>
                 <a:ea typeface="Calibri" pitchFamily="34" charset="-122"/>
@@ -5931,7 +5931,7 @@
             <a:r>
               <a:rPr lang="en-US" sz="1050" i="1" dirty="0">
                 <a:solidFill>
-                  <a:srgbClr val="64748B"/>
+                  <a:srgbClr val="78716C"/>
                 </a:solidFill>
                 <a:latin typeface="Calibri" pitchFamily="34" charset="0"/>
                 <a:ea typeface="Calibri" pitchFamily="34" charset="-122"/>
@@ -5994,7 +5994,7 @@
             <a:r>
               <a:rPr lang="en-US" sz="1300" b="1" dirty="0">
                 <a:solidFill>
-                  <a:srgbClr val="1E3A5F"/>
+                  <a:srgbClr val="1C1917"/>
                 </a:solidFill>
                 <a:latin typeface="Calibri" pitchFamily="34" charset="0"/>
                 <a:ea typeface="Calibri" pitchFamily="34" charset="-122"/>
@@ -6033,7 +6033,7 @@
             <a:r>
               <a:rPr lang="en-US" sz="1050" i="1" dirty="0">
                 <a:solidFill>
-                  <a:srgbClr val="64748B"/>
+                  <a:srgbClr val="78716C"/>
                 </a:solidFill>
                 <a:latin typeface="Calibri" pitchFamily="34" charset="0"/>
                 <a:ea typeface="Calibri" pitchFamily="34" charset="-122"/>
@@ -6096,7 +6096,7 @@
             <a:r>
               <a:rPr lang="en-US" sz="1300" b="1" dirty="0">
                 <a:solidFill>
-                  <a:srgbClr val="1E3A5F"/>
+                  <a:srgbClr val="1C1917"/>
                 </a:solidFill>
                 <a:latin typeface="Calibri" pitchFamily="34" charset="0"/>
                 <a:ea typeface="Calibri" pitchFamily="34" charset="-122"/>
@@ -6135,7 +6135,7 @@
             <a:r>
               <a:rPr lang="en-US" sz="1050" i="1" dirty="0">
                 <a:solidFill>
-                  <a:srgbClr val="64748B"/>
+                  <a:srgbClr val="78716C"/>
                 </a:solidFill>
                 <a:latin typeface="Calibri" pitchFamily="34" charset="0"/>
                 <a:ea typeface="Calibri" pitchFamily="34" charset="-122"/>
@@ -6198,7 +6198,7 @@
             <a:r>
               <a:rPr lang="en-US" sz="1300" b="1" dirty="0">
                 <a:solidFill>
-                  <a:srgbClr val="1E3A5F"/>
+                  <a:srgbClr val="1C1917"/>
                 </a:solidFill>
                 <a:latin typeface="Calibri" pitchFamily="34" charset="0"/>
                 <a:ea typeface="Calibri" pitchFamily="34" charset="-122"/>
@@ -6237,7 +6237,7 @@
             <a:r>
               <a:rPr lang="en-US" sz="1050" i="1" dirty="0">
                 <a:solidFill>
-                  <a:srgbClr val="64748B"/>
+                  <a:srgbClr val="78716C"/>
                 </a:solidFill>
                 <a:latin typeface="Calibri" pitchFamily="34" charset="0"/>
                 <a:ea typeface="Calibri" pitchFamily="34" charset="-122"/>
@@ -6300,7 +6300,7 @@
             <a:r>
               <a:rPr lang="en-US" sz="1300" b="1" dirty="0">
                 <a:solidFill>
-                  <a:srgbClr val="64748B"/>
+                  <a:srgbClr val="78716C"/>
                 </a:solidFill>
                 <a:latin typeface="Calibri" pitchFamily="34" charset="0"/>
                 <a:ea typeface="Calibri" pitchFamily="34" charset="-122"/>
@@ -6339,7 +6339,7 @@
             <a:r>
               <a:rPr lang="en-US" sz="1050" i="1" dirty="0">
                 <a:solidFill>
-                  <a:srgbClr val="64748B"/>
+                  <a:srgbClr val="78716C"/>
                 </a:solidFill>
                 <a:latin typeface="Calibri" pitchFamily="34" charset="0"/>
                 <a:ea typeface="Calibri" pitchFamily="34" charset="-122"/>
@@ -6402,7 +6402,7 @@
             <a:r>
               <a:rPr lang="en-US" sz="1300" b="1" dirty="0">
                 <a:solidFill>
-                  <a:srgbClr val="64748B"/>
+                  <a:srgbClr val="78716C"/>
                 </a:solidFill>
                 <a:latin typeface="Calibri" pitchFamily="34" charset="0"/>
                 <a:ea typeface="Calibri" pitchFamily="34" charset="-122"/>
@@ -6441,7 +6441,7 @@
             <a:r>
               <a:rPr lang="en-US" sz="1050" i="1" dirty="0">
                 <a:solidFill>
-                  <a:srgbClr val="64748B"/>
+                  <a:srgbClr val="78716C"/>
                 </a:solidFill>
                 <a:latin typeface="Calibri" pitchFamily="34" charset="0"/>
                 <a:ea typeface="Calibri" pitchFamily="34" charset="-122"/>
@@ -6467,7 +6467,7 @@
     <p:bg>
       <p:bgPr>
         <a:solidFill>
-          <a:srgbClr val="1E3A5F"/>
+          <a:srgbClr val="1C1917"/>
         </a:solidFill>
       </p:bgPr>
     </p:bg>
@@ -6500,7 +6500,7 @@
             <a:avLst/>
           </a:prstGeom>
           <a:solidFill>
-            <a:srgbClr val="0D9488">
+            <a:srgbClr val="10B981">
               <a:alpha val="15000"/>
             </a:srgbClr>
           </a:solidFill>
@@ -6573,7 +6573,7 @@
             <a:r>
               <a:rPr lang="en-US" sz="1600" i="1" dirty="0">
                 <a:solidFill>
-                  <a:srgbClr val="CCFBF1"/>
+                  <a:srgbClr val="D1FAE5"/>
                 </a:solidFill>
                 <a:latin typeface="Calibri" pitchFamily="34" charset="0"/>
                 <a:ea typeface="Calibri" pitchFamily="34" charset="-122"/>
@@ -6836,7 +6836,7 @@
             <a:avLst/>
           </a:prstGeom>
           <a:solidFill>
-            <a:srgbClr val="0D9488"/>
+            <a:srgbClr val="10B981"/>
           </a:solidFill>
           <a:ln/>
         </p:spPr>

</xml_diff>